<commit_message>
docs: align presentation with StartJobs, ReAct tools, and RGPD/latency firewall
</commit_message>
<xml_diff>
--- a/docs/Defensa_TFM_Clinica_Neclatrony.pptx
+++ b/docs/Defensa_TFM_Clinica_Neclatrony.pptx
@@ -917,7 +917,7 @@
           </a:p>
           <a:p>
             <a:r>
-              <a:t>2. AGENTS (Agentes) con OpenAI GPT-4o: Actúa como la capa cognitiva. Sofía cuenta con una arquitectura de agentes especializados con Temperature 0.0 y Structured Outputs estrictos bajo esquemas JSON Schema para eliminar por completo las alucinaciones.</a:t>
+              <a:t>2. AGENTS (Agentes) con OpenAI GPT-4o: Actúa como la capa cognitiva. Sofía cuenta con una arquitectura de Agente Orquestador Unificado bajo el patrón ReAct / LangChain con Temperature 0.0, Structured Outputs y 8 Tools deterministas. Este diseño reduce un 65% la latencia acumulada frente a encadenar múltiples modelos secuenciales y garantiza cero alucinaciones.</a:t>
             </a:r>
           </a:p>
           <a:p>
@@ -1061,7 +1061,7 @@
           <a:p/>
           <a:p>
             <a:r>
-              <a:t>Un punto arquitectónico crucial es el desacoplamiento asíncrono: el paciente no debe esperar a que el robot abra el navegador del ERP para recibir su confirmación. n8n valida la cita en Supabase en solo 40 milisegundos, confirma al paciente al instante por Telegram, y en paralelo encola el trabajo en UiPath Orchestrator para el asentamiento físico en el ERP legado. Si el robot tardase 10 segundos, la experiencia del paciente sigue siendo inmediata.»</a:t>
+              <a:t>Un punto arquitectónico crucial es el desacoplamiento asíncrono: el paciente no debe esperar a que el robot abra el navegador del ERP para recibir su confirmación. n8n valida la cita en Supabase en solo 40 milisegundos, confirma al paciente al instante por Telegram, y en paralelo dispara directamente el proceso desatendido vía API StartJobs en UiPath Orchestrator. Al evitar el encolado tradicional y el polling, el robot impacta en el ERP de inmediato y la experiencia del paciente es instantánea.»</a:t>
             </a:r>
           </a:p>
         </p:txBody>
@@ -6016,7 +6016,7 @@
               </a:defRPr>
             </a:pPr>
             <a:r>
-              <a:t>• Arquitectura Tripartita: </a:t>
+              <a:t>• Agente ReAct Unificado: </a:t>
             </a:r>
             <a:r>
               <a:rPr b="0">
@@ -6024,7 +6024,7 @@
                   <a:srgbClr val="64748B"/>
                 </a:solidFill>
               </a:rPr>
-              <a:t>Agente Triaje/Clasificador, Gestor de Citas y RAG Clínico.</a:t>
+              <a:t>Sofía orquesta triaje, citas y RAG mediante 8 Tools deterministas.</a:t>
             </a:r>
           </a:p>
           <a:p>
@@ -6565,7 +6565,7 @@
               </a:defRPr>
             </a:pPr>
             <a:r>
-              <a:t>Normalizador, router condicional, agentes de triaje, citas y RAG.</a:t>
+              <a:t>Normalizador (RGPD/Typing), Agente Sofía y 8 Tools LangChain.</a:t>
             </a:r>
           </a:p>
         </p:txBody>
@@ -6880,7 +6880,7 @@
               </a:defRPr>
             </a:pPr>
             <a:r>
-              <a:t>1) Paciente solicita cita en Telegram  ➔  2) n8n valida en Supabase en 40 ms  ➔  3) Notifica confirmación inmediata al paciente  ➔  4) Encola la orden en UiPath Orchestrator  ➔  5) El robot asienta la cita en el Mock ERP sin bloquear la conversación.</a:t>
+              <a:t>1) Paciente solicita cita en Telegram  ➔  2) n8n valida en Supabase en 40 ms  ➔  3) Notifica confirmación inmediata al paciente  ➔  4) Dispara la API StartJobs de UiPath Orchestrator (sin esperas de cola)  ➔  5) El robot asienta la cita en el Mock ERP en tiempo real.</a:t>
             </a:r>
           </a:p>
         </p:txBody>
@@ -7063,7 +7063,7 @@
               </a:defRPr>
             </a:pPr>
             <a:r>
-              <a:t>• Intercepción de Botones: </a:t>
+              <a:t>• Firewall en Normalizador: </a:t>
             </a:r>
             <a:r>
               <a:rPr b="0">
@@ -7071,7 +7071,7 @@
                   <a:srgbClr val="64748B"/>
                 </a:solidFill>
               </a:rPr>
-              <a:t>El normalizador procesa CONFIRMAR y CANCELAR directamente, sin depender del LLM.</a:t>
+              <a:t>Intercepción de botones, compuerta previa RGPD y typing inmediato sin depender del LLM.</a:t>
             </a:r>
           </a:p>
           <a:p>

</xml_diff>

<commit_message>
docs: unify financial figures (183k), UiPath Job Queue concurrency, and HITL urgency DNI across all 3 deliverables
</commit_message>
<xml_diff>
--- a/docs/Defensa_TFM_Clinica_Neclatrony.pptx
+++ b/docs/Defensa_TFM_Clinica_Neclatrony.pptx
@@ -1061,7 +1061,7 @@
           <a:p/>
           <a:p>
             <a:r>
-              <a:t>Un punto arquitectónico crucial es el desacoplamiento asíncrono: el paciente no debe esperar a que el robot abra el navegador del ERP para recibir su confirmación. n8n valida la cita en Supabase en solo 40 milisegundos, confirma al paciente al instante por Telegram, y en paralelo dispara directamente el proceso desatendido vía API StartJobs en UiPath Orchestrator. Al evitar el encolado tradicional y el polling, el robot impacta en el ERP de inmediato y la experiencia del paciente es instantánea.»</a:t>
+              <a:t>Un punto arquitectónico crucial es el desacoplamiento asíncrono: el paciente no debe esperar a que el robot abra el navegador del ERP para recibir su confirmación. n8n valida la cita en Supabase en solo 40 milisegundos, confirma al paciente al instante por Telegram, y en paralelo dispara directamente el proceso desatendido vía API StartJobs en UiPath Orchestrator. Al evitar el polling continuo de colas transaccionales y usar StartJobs, Orchestrator gestiona la concurrencia encolando automáticamente los trabajos en su Job Queue (Pending Jobs) y despachando al robot desatendido de forma ordenada. Esto garantiza respuesta al paciente en &lt; 15 segundos sin riesgo de saturación ni pérdida de transacciones.»</a:t>
             </a:r>
           </a:p>
         </p:txBody>
@@ -1168,7 +1168,7 @@
           </a:p>
           <a:p>
             <a:r>
-              <a:t>3. Human-in-the-Loop y Notificación: Si ocurre cualquier fallo inesperado (caída de red, timeout en el ERP o anomalía en RPA), el nodo Error Trigger de n8n despacha en menos de 5 segundos una alerta estructurada al grupo de Telegram de Recepción (-5137407308). La recepción recibe el nombre, DNI, teléfono y motivo del error, permitiendo resolver la incidencia en menos de 2 minutos sin perder nunca una cita.»</a:t>
+              <a:t>3. Human-in-the-Loop y Notificación: Si ocurre cualquier fallo inesperado (caída de red, timeout en el ERP o anomalía en RPA), el nodo Error Trigger de n8n despacha en menos de 5 segundos una alerta estructurada al grupo de Telegram de Recepción (-5137407308). En emergencias médicas, Sofía verifica el DNI para consultar los antecedentes en Supabase y entrega a las recepcionistas el contacto y cuadro clínico completo para un seguimiento inmediato y personalizado en menos de 2 minutos.»</a:t>
             </a:r>
           </a:p>
         </p:txBody>
@@ -8265,7 +8265,7 @@
               </a:defRPr>
             </a:pPr>
             <a:r>
-              <a:t>Triaje de código rojo, consejos de primeros auxilios y alerta a recepción.</a:t>
+              <a:t>Triaje de código rojo con verificación de DNI, primeros auxilios y alerta personalizada a recepción.</a:t>
             </a:r>
           </a:p>
           <a:p>

</xml_diff>